<commit_message>
feat(decks): add intentional cover framing
</commit_message>
<xml_diff>
--- a/artifacts/spikes/intent-profile-review-2026-07-15/board-presentation-infographic.pptx
+++ b/artifacts/spikes/intent-profile-review-2026-07-15/board-presentation-infographic.pptx
@@ -505,12 +505,12 @@
               <a:t>WorkshopLM source trace
 claim-bb80dd1be045-4-1
 Local PDF · GenAI Collective Chapter Startup FAQ.pdf · chunk 05
-claim-bb80dd1be045-29-2
-Local PDF · GenAI Collective Chapter Startup FAQ.pdf · chunk 30
 claim-60bb5377e97a-78-1
 https://newsletter.aicollective.com/ · chunk 79
-claim-60bb5377e97a-80-3
-https://newsletter.aicollective.com/ · chunk 81</a:t>
+claim-aic-event-formats
+https://newsletter.aicollective.com/ · Frequently Asked Questions · What’s The AI Collective itself?
+derived-30-day-launch-plan
+Derived from approved Workshop brief · validate with AI Collective HQ</a:t>
             </a:r>
             <a:endParaRPr lang="en-US" dirty="0"/>
           </a:p>
@@ -1012,7 +1012,7 @@
                 <a:ea typeface="Arial" pitchFamily="34" charset="-122"/>
                 <a:cs typeface="Arial" pitchFamily="34" charset="-120"/>
               </a:rPr>
-              <a:t>AI Collective chapter launch briefing</a:t>
+              <a:t>AI Collective chapter launch decision</a:t>
             </a:r>
             <a:endParaRPr lang="en-US" sz="2700" dirty="0"/>
           </a:p>
@@ -1121,7 +1121,7 @@
                 <a:ea typeface="Arial" pitchFamily="34" charset="-122"/>
                 <a:cs typeface="Arial" pitchFamily="34" charset="-120"/>
               </a:rPr>
-              <a:t>Become a go-to resource</a:t>
+              <a:t>Build the local front door to applied AI</a:t>
             </a:r>
             <a:endParaRPr lang="en-US" sz="1700" dirty="0"/>
           </a:p>
@@ -1164,7 +1164,7 @@
                 <a:ea typeface="Arial" pitchFamily="34" charset="-122"/>
                 <a:cs typeface="Arial" pitchFamily="34" charset="-120"/>
               </a:rPr>
-              <a:t>As a chapter lead, you’ll be seen as a leader and facilitator in your local AI scene.</a:t>
+              <a:t>A chapter lead becomes a visible facilitator and go-to resource for the local AI community.</a:t>
             </a:r>
             <a:endParaRPr lang="en-US" sz="1000" dirty="0"/>
           </a:p>
@@ -1290,158 +1290,6 @@
         <p:spPr>
           <a:xfrm>
             <a:off x="6839712" y="2048256"/>
-            <a:ext cx="4480560" cy="932688"/>
-          </a:xfrm>
-          <a:prstGeom prst="rect">
-            <a:avLst/>
-          </a:prstGeom>
-          <a:noFill/>
-          <a:ln/>
-        </p:spPr>
-        <p:txBody>
-          <a:bodyPr wrap="square" lIns="0" tIns="0" rIns="0" bIns="0" rtlCol="0" anchor="t">
-            <a:normAutofit/>
-          </a:bodyPr>
-          <a:lstStyle/>
-          <a:p>
-            <a:pPr indent="0" marL="0">
-              <a:buNone/>
-            </a:pPr>
-            <a:r>
-              <a:rPr lang="en-US" sz="1900" dirty="0">
-                <a:solidFill>
-                  <a:srgbClr val="171717"/>
-                </a:solidFill>
-                <a:latin typeface="Arial" pitchFamily="34" charset="0"/>
-                <a:ea typeface="Arial" pitchFamily="34" charset="-122"/>
-                <a:cs typeface="Arial" pitchFamily="34" charset="-120"/>
-              </a:rPr>
-              <a:t>Your events are financially sustainable</a:t>
-            </a:r>
-            <a:endParaRPr lang="en-US" sz="1900" dirty="0"/>
-          </a:p>
-        </p:txBody>
-      </p:sp>
-      <p:sp>
-        <p:nvSpPr>
-          <p:cNvPr id="14" name="Text 11"/>
-          <p:cNvSpPr/>
-          <p:nvPr/>
-        </p:nvSpPr>
-        <p:spPr>
-          <a:xfrm>
-            <a:off x="6839712" y="3346704"/>
-            <a:ext cx="4480560" cy="164592"/>
-          </a:xfrm>
-          <a:prstGeom prst="rect">
-            <a:avLst/>
-          </a:prstGeom>
-          <a:noFill/>
-          <a:ln/>
-        </p:spPr>
-        <p:txBody>
-          <a:bodyPr wrap="square" lIns="0" tIns="0" rIns="0" bIns="0" rtlCol="0" anchor="ctr">
-            <a:normAutofit/>
-          </a:bodyPr>
-          <a:lstStyle/>
-          <a:p>
-            <a:pPr indent="0" marL="0">
-              <a:buNone/>
-            </a:pPr>
-            <a:r>
-              <a:rPr lang="en-US" sz="650" dirty="0">
-                <a:solidFill>
-                  <a:srgbClr val="171717">
-                    <a:alpha val="58000"/>
-                  </a:srgbClr>
-                </a:solidFill>
-                <a:latin typeface="Arial" pitchFamily="34" charset="0"/>
-                <a:ea typeface="Arial" pitchFamily="34" charset="-122"/>
-                <a:cs typeface="Arial" pitchFamily="34" charset="-120"/>
-              </a:rPr>
-              <a:t>Source: Chapter Startup FAQ</a:t>
-            </a:r>
-            <a:endParaRPr lang="en-US" sz="650" dirty="0"/>
-          </a:p>
-        </p:txBody>
-      </p:sp>
-      <p:sp>
-        <p:nvSpPr>
-          <p:cNvPr id="15" name="Shape 12"/>
-          <p:cNvSpPr/>
-          <p:nvPr/>
-        </p:nvSpPr>
-        <p:spPr>
-          <a:xfrm>
-            <a:off x="658368" y="3922776"/>
-            <a:ext cx="5102352" cy="18288"/>
-          </a:xfrm>
-          <a:prstGeom prst="rect">
-            <a:avLst/>
-          </a:prstGeom>
-          <a:solidFill>
-            <a:srgbClr val="171717">
-              <a:alpha val="18000"/>
-            </a:srgbClr>
-          </a:solidFill>
-          <a:ln w="12700">
-            <a:solidFill>
-              <a:srgbClr val="171717">
-                <a:alpha val="0"/>
-              </a:srgbClr>
-            </a:solidFill>
-            <a:prstDash val="solid"/>
-          </a:ln>
-        </p:spPr>
-      </p:sp>
-      <p:sp>
-        <p:nvSpPr>
-          <p:cNvPr id="16" name="Text 13"/>
-          <p:cNvSpPr/>
-          <p:nvPr/>
-        </p:nvSpPr>
-        <p:spPr>
-          <a:xfrm>
-            <a:off x="658368" y="4178808"/>
-            <a:ext cx="457200" cy="256032"/>
-          </a:xfrm>
-          <a:prstGeom prst="rect">
-            <a:avLst/>
-          </a:prstGeom>
-          <a:noFill/>
-          <a:ln/>
-        </p:spPr>
-        <p:txBody>
-          <a:bodyPr wrap="square" lIns="0" tIns="0" rIns="0" bIns="0" rtlCol="0" anchor="ctr"/>
-          <a:lstStyle/>
-          <a:p>
-            <a:pPr indent="0" marL="0">
-              <a:buNone/>
-            </a:pPr>
-            <a:r>
-              <a:rPr lang="en-US" sz="1000" b="1" dirty="0">
-                <a:solidFill>
-                  <a:srgbClr val="FF640D"/>
-                </a:solidFill>
-                <a:latin typeface="Arial" pitchFamily="34" charset="0"/>
-                <a:ea typeface="Arial" pitchFamily="34" charset="-122"/>
-                <a:cs typeface="Arial" pitchFamily="34" charset="-120"/>
-              </a:rPr>
-              <a:t>03</a:t>
-            </a:r>
-            <a:endParaRPr lang="en-US" sz="1000" dirty="0"/>
-          </a:p>
-        </p:txBody>
-      </p:sp>
-      <p:sp>
-        <p:nvSpPr>
-          <p:cNvPr id="17" name="Text 14"/>
-          <p:cNvSpPr/>
-          <p:nvPr/>
-        </p:nvSpPr>
-        <p:spPr>
-          <a:xfrm>
-            <a:off x="1280160" y="4123944"/>
             <a:ext cx="4480560" cy="621792"/>
           </a:xfrm>
           <a:prstGeom prst="rect">
@@ -1476,13 +1324,13 @@
       </p:sp>
       <p:sp>
         <p:nvSpPr>
-          <p:cNvPr id="18" name="Text 15"/>
-          <p:cNvSpPr/>
-          <p:nvPr/>
-        </p:nvSpPr>
-        <p:spPr>
-          <a:xfrm>
-            <a:off x="1280160" y="4782312"/>
+          <p:cNvPr id="14" name="Text 11"/>
+          <p:cNvSpPr/>
+          <p:nvPr/>
+        </p:nvSpPr>
+        <p:spPr>
+          <a:xfrm>
+            <a:off x="6839712" y="2706624"/>
             <a:ext cx="4480560" cy="457200"/>
           </a:xfrm>
           <a:prstGeom prst="rect">
@@ -1519,13 +1367,13 @@
       </p:sp>
       <p:sp>
         <p:nvSpPr>
-          <p:cNvPr id="19" name="Text 16"/>
-          <p:cNvSpPr/>
-          <p:nvPr/>
-        </p:nvSpPr>
-        <p:spPr>
-          <a:xfrm>
-            <a:off x="1280160" y="5422392"/>
+          <p:cNvPr id="15" name="Text 12"/>
+          <p:cNvSpPr/>
+          <p:nvPr/>
+        </p:nvSpPr>
+        <p:spPr>
+          <a:xfrm>
+            <a:off x="6839712" y="3346704"/>
             <a:ext cx="4480560" cy="164592"/>
           </a:xfrm>
           <a:prstGeom prst="rect">
@@ -1562,13 +1410,13 @@
       </p:sp>
       <p:sp>
         <p:nvSpPr>
-          <p:cNvPr id="20" name="Shape 17"/>
-          <p:cNvSpPr/>
-          <p:nvPr/>
-        </p:nvSpPr>
-        <p:spPr>
-          <a:xfrm>
-            <a:off x="6217920" y="3922776"/>
+          <p:cNvPr id="16" name="Shape 13"/>
+          <p:cNvSpPr/>
+          <p:nvPr/>
+        </p:nvSpPr>
+        <p:spPr>
+          <a:xfrm>
+            <a:off x="658368" y="3922776"/>
             <a:ext cx="5102352" cy="18288"/>
           </a:xfrm>
           <a:prstGeom prst="rect">
@@ -1591,13 +1439,13 @@
       </p:sp>
       <p:sp>
         <p:nvSpPr>
-          <p:cNvPr id="21" name="Text 18"/>
-          <p:cNvSpPr/>
-          <p:nvPr/>
-        </p:nvSpPr>
-        <p:spPr>
-          <a:xfrm>
-            <a:off x="6217920" y="4178808"/>
+          <p:cNvPr id="17" name="Text 14"/>
+          <p:cNvSpPr/>
+          <p:nvPr/>
+        </p:nvSpPr>
+        <p:spPr>
+          <a:xfrm>
+            <a:off x="658368" y="4178808"/>
             <a:ext cx="457200" cy="256032"/>
           </a:xfrm>
           <a:prstGeom prst="rect">
@@ -1622,7 +1470,7 @@
                 <a:ea typeface="Arial" pitchFamily="34" charset="-122"/>
                 <a:cs typeface="Arial" pitchFamily="34" charset="-120"/>
               </a:rPr>
-              <a:t>04</a:t>
+              <a:t>03</a:t>
             </a:r>
             <a:endParaRPr lang="en-US" sz="1000" dirty="0"/>
           </a:p>
@@ -1630,13 +1478,13 @@
       </p:sp>
       <p:sp>
         <p:nvSpPr>
-          <p:cNvPr id="22" name="Text 19"/>
-          <p:cNvSpPr/>
-          <p:nvPr/>
-        </p:nvSpPr>
-        <p:spPr>
-          <a:xfrm>
-            <a:off x="6839712" y="4123944"/>
+          <p:cNvPr id="18" name="Text 15"/>
+          <p:cNvSpPr/>
+          <p:nvPr/>
+        </p:nvSpPr>
+        <p:spPr>
+          <a:xfrm>
+            <a:off x="1280160" y="4123944"/>
             <a:ext cx="4480560" cy="621792"/>
           </a:xfrm>
           <a:prstGeom prst="rect">
@@ -1663,7 +1511,7 @@
                 <a:ea typeface="Arial" pitchFamily="34" charset="-122"/>
                 <a:cs typeface="Arial" pitchFamily="34" charset="-120"/>
               </a:rPr>
-              <a:t>Start a chapter in your city</a:t>
+              <a:t>Start with one repeatable event format</a:t>
             </a:r>
             <a:endParaRPr lang="en-US" sz="1700" dirty="0"/>
           </a:p>
@@ -1671,13 +1519,13 @@
       </p:sp>
       <p:sp>
         <p:nvSpPr>
-          <p:cNvPr id="23" name="Text 20"/>
-          <p:cNvSpPr/>
-          <p:nvPr/>
-        </p:nvSpPr>
-        <p:spPr>
-          <a:xfrm>
-            <a:off x="6839712" y="4782312"/>
+          <p:cNvPr id="19" name="Text 16"/>
+          <p:cNvSpPr/>
+          <p:nvPr/>
+        </p:nvSpPr>
+        <p:spPr>
+          <a:xfrm>
+            <a:off x="1280160" y="4782312"/>
             <a:ext cx="4480560" cy="457200"/>
           </a:xfrm>
           <a:prstGeom prst="rect">
@@ -1706,7 +1554,7 @@
                 <a:ea typeface="Arial" pitchFamily="34" charset="-122"/>
                 <a:cs typeface="Arial" pitchFamily="34" charset="-120"/>
               </a:rPr>
-              <a:t>You can also attend an event, volunteer to organize, or pitch a Byte article.</a:t>
+              <a:t>The network already runs Demo Nights, hackathons, private dinners, and workshops. Choose one format that matches the local audience and can repeat.</a:t>
             </a:r>
             <a:endParaRPr lang="en-US" sz="1000" dirty="0"/>
           </a:p>
@@ -1714,13 +1562,13 @@
       </p:sp>
       <p:sp>
         <p:nvSpPr>
-          <p:cNvPr id="24" name="Text 21"/>
-          <p:cNvSpPr/>
-          <p:nvPr/>
-        </p:nvSpPr>
-        <p:spPr>
-          <a:xfrm>
-            <a:off x="6839712" y="5422392"/>
+          <p:cNvPr id="20" name="Text 17"/>
+          <p:cNvSpPr/>
+          <p:nvPr/>
+        </p:nvSpPr>
+        <p:spPr>
+          <a:xfrm>
+            <a:off x="1280160" y="5422392"/>
             <a:ext cx="4480560" cy="164592"/>
           </a:xfrm>
           <a:prstGeom prst="rect">
@@ -1749,7 +1597,7 @@
                 <a:ea typeface="Arial" pitchFamily="34" charset="-122"/>
                 <a:cs typeface="Arial" pitchFamily="34" charset="-120"/>
               </a:rPr>
-              <a:t>Source: AI Collective Newsletter</a:t>
+              <a:t>Source: AI Collective Newsletter · FAQ</a:t>
             </a:r>
             <a:endParaRPr lang="en-US" sz="650" dirty="0"/>
           </a:p>
@@ -1757,7 +1605,202 @@
       </p:sp>
       <p:sp>
         <p:nvSpPr>
-          <p:cNvPr id="26" name="Text 22"/>
+          <p:cNvPr id="21" name="Shape 18"/>
+          <p:cNvSpPr/>
+          <p:nvPr/>
+        </p:nvSpPr>
+        <p:spPr>
+          <a:xfrm>
+            <a:off x="6217920" y="3922776"/>
+            <a:ext cx="5102352" cy="18288"/>
+          </a:xfrm>
+          <a:prstGeom prst="rect">
+            <a:avLst/>
+          </a:prstGeom>
+          <a:solidFill>
+            <a:srgbClr val="171717">
+              <a:alpha val="18000"/>
+            </a:srgbClr>
+          </a:solidFill>
+          <a:ln w="12700">
+            <a:solidFill>
+              <a:srgbClr val="171717">
+                <a:alpha val="0"/>
+              </a:srgbClr>
+            </a:solidFill>
+            <a:prstDash val="solid"/>
+          </a:ln>
+        </p:spPr>
+      </p:sp>
+      <p:sp>
+        <p:nvSpPr>
+          <p:cNvPr id="22" name="Text 19"/>
+          <p:cNvSpPr/>
+          <p:nvPr/>
+        </p:nvSpPr>
+        <p:spPr>
+          <a:xfrm>
+            <a:off x="6217920" y="4178808"/>
+            <a:ext cx="457200" cy="256032"/>
+          </a:xfrm>
+          <a:prstGeom prst="rect">
+            <a:avLst/>
+          </a:prstGeom>
+          <a:noFill/>
+          <a:ln/>
+        </p:spPr>
+        <p:txBody>
+          <a:bodyPr wrap="square" lIns="0" tIns="0" rIns="0" bIns="0" rtlCol="0" anchor="ctr"/>
+          <a:lstStyle/>
+          <a:p>
+            <a:pPr indent="0" marL="0">
+              <a:buNone/>
+            </a:pPr>
+            <a:r>
+              <a:rPr lang="en-US" sz="1000" b="1" dirty="0">
+                <a:solidFill>
+                  <a:srgbClr val="FF640D"/>
+                </a:solidFill>
+                <a:latin typeface="Arial" pitchFamily="34" charset="0"/>
+                <a:ea typeface="Arial" pitchFamily="34" charset="-122"/>
+                <a:cs typeface="Arial" pitchFamily="34" charset="-120"/>
+              </a:rPr>
+              <a:t>04</a:t>
+            </a:r>
+            <a:endParaRPr lang="en-US" sz="1000" dirty="0"/>
+          </a:p>
+        </p:txBody>
+      </p:sp>
+      <p:sp>
+        <p:nvSpPr>
+          <p:cNvPr id="23" name="Text 20"/>
+          <p:cNvSpPr/>
+          <p:nvPr/>
+        </p:nvSpPr>
+        <p:spPr>
+          <a:xfrm>
+            <a:off x="6839712" y="4123944"/>
+            <a:ext cx="4480560" cy="621792"/>
+          </a:xfrm>
+          <a:prstGeom prst="rect">
+            <a:avLst/>
+          </a:prstGeom>
+          <a:noFill/>
+          <a:ln/>
+        </p:spPr>
+        <p:txBody>
+          <a:bodyPr wrap="square" lIns="0" tIns="0" rIns="0" bIns="0" rtlCol="0" anchor="t">
+            <a:normAutofit/>
+          </a:bodyPr>
+          <a:lstStyle/>
+          <a:p>
+            <a:pPr indent="0" marL="0">
+              <a:buNone/>
+            </a:pPr>
+            <a:r>
+              <a:rPr lang="en-US" sz="1700" dirty="0">
+                <a:solidFill>
+                  <a:srgbClr val="171717"/>
+                </a:solidFill>
+                <a:latin typeface="Arial" pitchFamily="34" charset="0"/>
+                <a:ea typeface="Arial" pitchFamily="34" charset="-122"/>
+                <a:cs typeface="Arial" pitchFamily="34" charset="-120"/>
+              </a:rPr>
+              <a:t>A four-week launch sequence</a:t>
+            </a:r>
+            <a:endParaRPr lang="en-US" sz="1700" dirty="0"/>
+          </a:p>
+        </p:txBody>
+      </p:sp>
+      <p:sp>
+        <p:nvSpPr>
+          <p:cNvPr id="24" name="Text 21"/>
+          <p:cNvSpPr/>
+          <p:nvPr/>
+        </p:nvSpPr>
+        <p:spPr>
+          <a:xfrm>
+            <a:off x="6839712" y="4782312"/>
+            <a:ext cx="4480560" cy="457200"/>
+          </a:xfrm>
+          <a:prstGeom prst="rect">
+            <a:avLst/>
+          </a:prstGeom>
+          <a:noFill/>
+          <a:ln/>
+        </p:spPr>
+        <p:txBody>
+          <a:bodyPr wrap="square" lIns="0" tIns="0" rIns="0" bIns="0" rtlCol="0" anchor="t">
+            <a:normAutofit/>
+          </a:bodyPr>
+          <a:lstStyle/>
+          <a:p>
+            <a:pPr indent="0" marL="0">
+              <a:buNone/>
+            </a:pPr>
+            <a:r>
+              <a:rPr lang="en-US" sz="1000" dirty="0">
+                <a:solidFill>
+                  <a:srgbClr val="171717">
+                    <a:alpha val="72000"/>
+                  </a:srgbClr>
+                </a:solidFill>
+                <a:latin typeface="Arial" pitchFamily="34" charset="0"/>
+                <a:ea typeface="Arial" pitchFamily="34" charset="-122"/>
+                <a:cs typeface="Arial" pitchFamily="34" charset="-120"/>
+              </a:rPr>
+              <a:t>WorkshopLM recommendation derived from the chapter brief; confirm timing and required approvals with AI Collective HQ.</a:t>
+            </a:r>
+            <a:endParaRPr lang="en-US" sz="1000" dirty="0"/>
+          </a:p>
+        </p:txBody>
+      </p:sp>
+      <p:sp>
+        <p:nvSpPr>
+          <p:cNvPr id="25" name="Text 22"/>
+          <p:cNvSpPr/>
+          <p:nvPr/>
+        </p:nvSpPr>
+        <p:spPr>
+          <a:xfrm>
+            <a:off x="6839712" y="5422392"/>
+            <a:ext cx="4480560" cy="164592"/>
+          </a:xfrm>
+          <a:prstGeom prst="rect">
+            <a:avLst/>
+          </a:prstGeom>
+          <a:noFill/>
+          <a:ln/>
+        </p:spPr>
+        <p:txBody>
+          <a:bodyPr wrap="square" lIns="0" tIns="0" rIns="0" bIns="0" rtlCol="0" anchor="ctr">
+            <a:normAutofit/>
+          </a:bodyPr>
+          <a:lstStyle/>
+          <a:p>
+            <a:pPr indent="0" marL="0">
+              <a:buNone/>
+            </a:pPr>
+            <a:r>
+              <a:rPr lang="en-US" sz="650" dirty="0">
+                <a:solidFill>
+                  <a:srgbClr val="171717">
+                    <a:alpha val="58000"/>
+                  </a:srgbClr>
+                </a:solidFill>
+                <a:latin typeface="Arial" pitchFamily="34" charset="0"/>
+                <a:ea typeface="Arial" pitchFamily="34" charset="-122"/>
+                <a:cs typeface="Arial" pitchFamily="34" charset="-120"/>
+              </a:rPr>
+              <a:t>Source: Derived plan · HQ validation required</a:t>
+            </a:r>
+            <a:endParaRPr lang="en-US" sz="650" dirty="0"/>
+          </a:p>
+        </p:txBody>
+      </p:sp>
+      <p:sp>
+        <p:nvSpPr>
+          <p:cNvPr id="27" name="Text 23"/>
           <p:cNvSpPr/>
           <p:nvPr/>
         </p:nvSpPr>

</xml_diff>

<commit_message>
docs(evidence): refresh intent profile proofs
</commit_message>
<xml_diff>
--- a/artifacts/spikes/intent-profile-review-2026-07-15/board-presentation-infographic.pptx
+++ b/artifacts/spikes/intent-profile-review-2026-07-15/board-presentation-infographic.pptx
@@ -1316,7 +1316,7 @@
                 <a:ea typeface="Arial" pitchFamily="34" charset="-122"/>
                 <a:cs typeface="Arial" pitchFamily="34" charset="-120"/>
               </a:rPr>
-              <a:t>180+ chapters across 40+ countries</a:t>
+              <a:t>180+ chapters, 40+ countries, 400+ organizers</a:t>
             </a:r>
             <a:endParaRPr lang="en-US" sz="1700" dirty="0"/>
           </a:p>
@@ -1359,7 +1359,7 @@
                 <a:ea typeface="Arial" pitchFamily="34" charset="-122"/>
                 <a:cs typeface="Arial" pitchFamily="34" charset="-120"/>
               </a:rPr>
-              <a:t>400+ volunteer organizers, with a community that includes everyone from solo founders to teams at the biggest AI labs in the world.</a:t>
+              <a:t>A global community that includes everyone from solo founders to teams at the biggest AI labs in the world.</a:t>
             </a:r>
             <a:endParaRPr lang="en-US" sz="1000" dirty="0"/>
           </a:p>

</xml_diff>